<commit_message>
Adicionado janela de logs
</commit_message>
<xml_diff>
--- a/Arquitetura do Software.pptx
+++ b/Arquitetura do Software.pptx
@@ -126,7 +126,7 @@
   <pc:docChgLst>
     <pc:chgData name="Leandro M Machado" userId="d82476bb6fadd58c" providerId="LiveId" clId="{A08595F5-0EB1-4D5B-95C0-C8D895760D55}"/>
     <pc:docChg chg="undo custSel addSld modSld">
-      <pc:chgData name="Leandro M Machado" userId="d82476bb6fadd58c" providerId="LiveId" clId="{A08595F5-0EB1-4D5B-95C0-C8D895760D55}" dt="2025-04-28T13:50:43.852" v="649" actId="14100"/>
+      <pc:chgData name="Leandro M Machado" userId="d82476bb6fadd58c" providerId="LiveId" clId="{A08595F5-0EB1-4D5B-95C0-C8D895760D55}" dt="2025-04-28T15:26:39.943" v="663" actId="20577"/>
       <pc:docMkLst>
         <pc:docMk/>
       </pc:docMkLst>
@@ -249,13 +249,13 @@
         </pc:picChg>
       </pc:sldChg>
       <pc:sldChg chg="addSp delSp modSp new mod">
-        <pc:chgData name="Leandro M Machado" userId="d82476bb6fadd58c" providerId="LiveId" clId="{A08595F5-0EB1-4D5B-95C0-C8D895760D55}" dt="2025-04-28T13:50:43.852" v="649" actId="14100"/>
+        <pc:chgData name="Leandro M Machado" userId="d82476bb6fadd58c" providerId="LiveId" clId="{A08595F5-0EB1-4D5B-95C0-C8D895760D55}" dt="2025-04-28T15:26:39.943" v="663" actId="20577"/>
         <pc:sldMkLst>
           <pc:docMk/>
           <pc:sldMk cId="2790638146" sldId="258"/>
         </pc:sldMkLst>
         <pc:spChg chg="mod">
-          <ac:chgData name="Leandro M Machado" userId="d82476bb6fadd58c" providerId="LiveId" clId="{A08595F5-0EB1-4D5B-95C0-C8D895760D55}" dt="2025-04-28T13:24:39.028" v="459"/>
+          <ac:chgData name="Leandro M Machado" userId="d82476bb6fadd58c" providerId="LiveId" clId="{A08595F5-0EB1-4D5B-95C0-C8D895760D55}" dt="2025-04-28T15:26:39.943" v="663" actId="20577"/>
           <ac:spMkLst>
             <pc:docMk/>
             <pc:sldMk cId="2790638146" sldId="258"/>
@@ -286,8 +286,8 @@
             <ac:picMk id="5" creationId="{3390B671-155B-40EC-4822-CF705D8D34DD}"/>
           </ac:picMkLst>
         </pc:picChg>
-        <pc:picChg chg="add mod">
-          <ac:chgData name="Leandro M Machado" userId="d82476bb6fadd58c" providerId="LiveId" clId="{A08595F5-0EB1-4D5B-95C0-C8D895760D55}" dt="2025-04-28T13:26:07.489" v="518" actId="1076"/>
+        <pc:picChg chg="add del mod">
+          <ac:chgData name="Leandro M Machado" userId="d82476bb6fadd58c" providerId="LiveId" clId="{A08595F5-0EB1-4D5B-95C0-C8D895760D55}" dt="2025-04-28T15:26:35.812" v="650" actId="478"/>
           <ac:picMkLst>
             <pc:docMk/>
             <pc:sldMk cId="2790638146" sldId="258"/>
@@ -4400,6 +4400,26 @@
               </a:rPr>
               <a:t>Módulos</a:t>
             </a:r>
+            <a:r>
+              <a:rPr lang="en-US" b="1" i="0" dirty="0">
+                <a:solidFill>
+                  <a:srgbClr val="D8DEE9"/>
+                </a:solidFill>
+                <a:effectLst/>
+                <a:latin typeface="Segoe WPC"/>
+              </a:rPr>
+              <a:t> </a:t>
+            </a:r>
+            <a:r>
+              <a:rPr lang="en-US" b="1" i="0" dirty="0" err="1">
+                <a:solidFill>
+                  <a:srgbClr val="D8DEE9"/>
+                </a:solidFill>
+                <a:effectLst/>
+                <a:latin typeface="Segoe WPC"/>
+              </a:rPr>
+              <a:t>implementada</a:t>
+            </a:r>
             <a:br>
               <a:rPr lang="en-US" b="1" i="0" dirty="0">
                 <a:solidFill>
@@ -4415,52 +4435,22 @@
       </p:sp>
       <p:pic>
         <p:nvPicPr>
-          <p:cNvPr id="7" name="Imagem 6">
-            <a:extLst>
-              <a:ext uri="{FF2B5EF4-FFF2-40B4-BE49-F238E27FC236}">
-                <a16:creationId xmlns:a16="http://schemas.microsoft.com/office/drawing/2014/main" id="{B86D8FD8-9CC0-7E13-C201-06D8A7D5ECBE}"/>
+          <p:cNvPr id="11" name="Espaço Reservado para Conteúdo 10">
+            <a:extLst>
+              <a:ext uri="{FF2B5EF4-FFF2-40B4-BE49-F238E27FC236}">
+                <a16:creationId xmlns:a16="http://schemas.microsoft.com/office/drawing/2014/main" id="{AF984A2B-80B3-A209-419B-748939C7348D}"/>
               </a:ext>
             </a:extLst>
           </p:cNvPr>
           <p:cNvPicPr>
-            <a:picLocks noChangeAspect="1"/>
+            <a:picLocks noGrp="1" noChangeAspect="1"/>
           </p:cNvPicPr>
-          <p:nvPr/>
+          <p:nvPr>
+            <p:ph idx="1"/>
+          </p:nvPr>
         </p:nvPicPr>
         <p:blipFill>
           <a:blip r:embed="rId2"/>
-          <a:stretch>
-            <a:fillRect/>
-          </a:stretch>
-        </p:blipFill>
-        <p:spPr>
-          <a:xfrm>
-            <a:off x="8178800" y="6371230"/>
-            <a:ext cx="4013200" cy="523846"/>
-          </a:xfrm>
-          <a:prstGeom prst="rect">
-            <a:avLst/>
-          </a:prstGeom>
-        </p:spPr>
-      </p:pic>
-      <p:pic>
-        <p:nvPicPr>
-          <p:cNvPr id="11" name="Espaço Reservado para Conteúdo 10">
-            <a:extLst>
-              <a:ext uri="{FF2B5EF4-FFF2-40B4-BE49-F238E27FC236}">
-                <a16:creationId xmlns:a16="http://schemas.microsoft.com/office/drawing/2014/main" id="{AF984A2B-80B3-A209-419B-748939C7348D}"/>
-              </a:ext>
-            </a:extLst>
-          </p:cNvPr>
-          <p:cNvPicPr>
-            <a:picLocks noGrp="1" noChangeAspect="1"/>
-          </p:cNvPicPr>
-          <p:nvPr>
-            <p:ph idx="1"/>
-          </p:nvPr>
-        </p:nvPicPr>
-        <p:blipFill>
-          <a:blip r:embed="rId3"/>
           <a:stretch>
             <a:fillRect/>
           </a:stretch>

</xml_diff>